<commit_message>
Document approximate Parquet size across project
</commit_message>
<xml_diff>
--- a/0. Priorización de vuelos con riesgo de retraso.pptx
+++ b/0. Priorización de vuelos con riesgo de retraso.pptx
@@ -8685,7 +8685,7 @@
                 <a:ea typeface="Arial" pitchFamily="34" charset="-122"/>
                 <a:cs typeface="Arial" pitchFamily="34" charset="-120"/>
               </a:rPr>
-              <a:t>1,3 GB</a:t>
+              <a:t>≈0,8 GB</a:t>
             </a:r>
             <a:endParaRPr lang="en-US" sz="3000" dirty="0"/>
           </a:p>
@@ -8729,7 +8729,7 @@
                 <a:ea typeface="Arial" pitchFamily="34" charset="-122"/>
                 <a:cs typeface="Arial" pitchFamily="34" charset="-120"/>
               </a:rPr>
-              <a:t>de RAM libre en un equipo de 8 GB</a:t>
+              <a:t>Parquet combinado (EDA*)</a:t>
             </a:r>
             <a:endParaRPr lang="en-US" sz="1300" dirty="0"/>
           </a:p>
@@ -9366,7 +9366,7 @@
               <a:buNone/>
             </a:pPr>
             <a:r>
-              <a:rPr lang="en-US" sz="1200" dirty="0">
+              <a:rPr lang="en-US" sz="900" dirty="0">
                 <a:solidFill>
                   <a:srgbClr val="55606B"/>
                 </a:solidFill>
@@ -9374,7 +9374,7 @@
                 <a:ea typeface="Arial" pitchFamily="34" charset="-122"/>
                 <a:cs typeface="Arial" pitchFamily="34" charset="-120"/>
               </a:rPr>
-              <a:t>Fuente: Flight Delay Dataset 2018–2022 (Kaggle) · Notebook integrado, secciones 1 y 2</a:t>
+              <a:t>Fuente: Kaggle y notebook integrado. *≈0,8 GB, ≈92 % menos que CSV. Cifra registrada en EDA previo, no revalidada en esta copia.</a:t>
             </a:r>
             <a:endParaRPr lang="en-US" sz="1200" dirty="0"/>
           </a:p>

</xml_diff>